<commit_message>
Add About Me slide with education, work experience, organization and photo
Co-Authored-By: Claude Opus 5.5 <noreply@anthropic.com>
Claude-Session: https://claude.ai/code/session_01Cx9kswyecF7JAB1Rr5vVcV
</commit_message>
<xml_diff>
--- a/nedp_deck/NEDP_MidYear_Review_2026_Editable.pptx
+++ b/nedp_deck/NEDP_MidYear_Review_2026_Editable.pptx
@@ -51544,7 +51544,42 @@
         </p:nvSpPr>
         <p:spPr>
           <a:xfrm>
-            <a:off x="561975" y="1514475"/>
+            <a:off x="561975" y="1525143"/>
+            <a:ext cx="960536" cy="104775"/>
+          </a:xfrm>
+          <a:prstGeom prst="rect">
+            <a:avLst/>
+          </a:prstGeom>
+          <a:noFill/>
+        </p:spPr>
+        <p:txBody>
+          <a:bodyPr wrap="none" lIns="0" rIns="0" tIns="0" bIns="0" anchor="t">
+            <a:spAutoFit/>
+          </a:bodyPr>
+          <a:lstStyle/>
+          <a:p>
+            <a:pPr algn="l"/>
+            <a:r>
+              <a:rPr sz="727" b="1">
+                <a:solidFill>
+                  <a:srgbClr val="FF5A1F"/>
+                </a:solidFill>
+                <a:latin typeface="Arial"/>
+              </a:rPr>
+              <a:t>PROFILE</a:t>
+            </a:r>
+          </a:p>
+        </p:txBody>
+      </p:sp>
+      <p:sp>
+        <p:nvSpPr>
+          <p:cNvPr id="7" name="TextBox 6"/>
+          <p:cNvSpPr txBox="1"/>
+          <p:nvPr/>
+        </p:nvSpPr>
+        <p:spPr>
+          <a:xfrm>
+            <a:off x="561975" y="1948457"/>
             <a:ext cx="2915989" cy="238125"/>
           </a:xfrm>
           <a:prstGeom prst="rect">
@@ -51591,14 +51626,14 @@
       </p:sp>
       <p:sp>
         <p:nvSpPr>
-          <p:cNvPr id="7" name="TextBox 6"/>
-          <p:cNvSpPr txBox="1"/>
-          <p:nvPr/>
-        </p:nvSpPr>
-        <p:spPr>
-          <a:xfrm>
-            <a:off x="561975" y="1787270"/>
-            <a:ext cx="2679203" cy="161925"/>
+          <p:cNvPr id="8" name="TextBox 7"/>
+          <p:cNvSpPr txBox="1"/>
+          <p:nvPr/>
+        </p:nvSpPr>
+        <p:spPr>
+          <a:xfrm>
+            <a:off x="561975" y="2550461"/>
+            <a:ext cx="2371576" cy="161925"/>
           </a:xfrm>
           <a:prstGeom prst="rect">
             <a:avLst/>
@@ -51619,817 +51654,1267 @@
                 </a:solidFill>
                 <a:latin typeface="Arial"/>
               </a:rPr>
+              <a:t>PT </a:t>
+            </a:r>
+            <a:r>
+              <a:rPr sz="1164" b="1">
+                <a:solidFill>
+                  <a:srgbClr val="FF5A1F"/>
+                </a:solidFill>
+                <a:latin typeface="Arial"/>
+              </a:rPr>
+              <a:t>Triatra </a:t>
+            </a:r>
+            <a:r>
+              <a:rPr sz="1164" b="1">
+                <a:solidFill>
+                  <a:srgbClr val="FF5A1F"/>
+                </a:solidFill>
+                <a:latin typeface="Arial"/>
+              </a:rPr>
+              <a:t>Sinergia </a:t>
+            </a:r>
+            <a:r>
+              <a:rPr sz="1164" b="1">
+                <a:solidFill>
+                  <a:srgbClr val="FF5A1F"/>
+                </a:solidFill>
+                <a:latin typeface="Arial"/>
+              </a:rPr>
+              <a:t>Pratama</a:t>
+            </a:r>
+          </a:p>
+        </p:txBody>
+      </p:sp>
+      <p:sp>
+        <p:nvSpPr>
+          <p:cNvPr id="9" name="TextBox 8"/>
+          <p:cNvSpPr txBox="1"/>
+          <p:nvPr/>
+        </p:nvSpPr>
+        <p:spPr>
+          <a:xfrm>
+            <a:off x="561975" y="3236666"/>
+            <a:ext cx="900261" cy="104775"/>
+          </a:xfrm>
+          <a:prstGeom prst="rect">
+            <a:avLst/>
+          </a:prstGeom>
+          <a:noFill/>
+        </p:spPr>
+        <p:txBody>
+          <a:bodyPr wrap="none" lIns="0" rIns="0" tIns="0" bIns="0" anchor="t">
+            <a:spAutoFit/>
+          </a:bodyPr>
+          <a:lstStyle/>
+          <a:p>
+            <a:pPr algn="l"/>
+            <a:r>
+              <a:rPr sz="691" b="0">
+                <a:solidFill>
+                  <a:srgbClr val="6F6963"/>
+                </a:solidFill>
+                <a:latin typeface="Arial"/>
+              </a:rPr>
+              <a:t>POSITION</a:t>
+            </a:r>
+          </a:p>
+        </p:txBody>
+      </p:sp>
+      <p:sp>
+        <p:nvSpPr>
+          <p:cNvPr id="10" name="TextBox 9"/>
+          <p:cNvSpPr txBox="1"/>
+          <p:nvPr/>
+        </p:nvSpPr>
+        <p:spPr>
+          <a:xfrm>
+            <a:off x="561975" y="3338393"/>
+            <a:ext cx="2115442" cy="142875"/>
+          </a:xfrm>
+          <a:prstGeom prst="rect">
+            <a:avLst/>
+          </a:prstGeom>
+          <a:noFill/>
+        </p:spPr>
+        <p:txBody>
+          <a:bodyPr wrap="none" lIns="0" rIns="0" tIns="0" bIns="0" anchor="t">
+            <a:spAutoFit/>
+          </a:bodyPr>
+          <a:lstStyle/>
+          <a:p>
+            <a:pPr algn="l"/>
+            <a:r>
+              <a:rPr sz="945" b="0">
+                <a:solidFill>
+                  <a:srgbClr val="F4F1EE"/>
+                </a:solidFill>
+                <a:latin typeface="Arial"/>
+              </a:rPr>
               <a:t>Marketing </a:t>
             </a:r>
             <a:r>
-              <a:rPr sz="1164" b="1">
+              <a:rPr sz="945" b="0">
+                <a:solidFill>
+                  <a:srgbClr val="F4F1EE"/>
+                </a:solidFill>
+                <a:latin typeface="Arial"/>
+              </a:rPr>
+              <a:t>Strategic </a:t>
+            </a:r>
+            <a:r>
+              <a:rPr sz="945" b="0">
+                <a:solidFill>
+                  <a:srgbClr val="F4F1EE"/>
+                </a:solidFill>
+                <a:latin typeface="Arial"/>
+              </a:rPr>
+              <a:t>2 </a:t>
+            </a:r>
+            <a:r>
+              <a:rPr sz="945" b="0">
+                <a:solidFill>
+                  <a:srgbClr val="F4F1EE"/>
+                </a:solidFill>
+                <a:latin typeface="Arial"/>
+              </a:rPr>
+              <a:t>Associate</a:t>
+            </a:r>
+          </a:p>
+        </p:txBody>
+      </p:sp>
+      <p:sp>
+        <p:nvSpPr>
+          <p:cNvPr id="11" name="TextBox 10"/>
+          <p:cNvSpPr txBox="1"/>
+          <p:nvPr/>
+        </p:nvSpPr>
+        <p:spPr>
+          <a:xfrm>
+            <a:off x="561975" y="3937349"/>
+            <a:ext cx="865137" cy="104775"/>
+          </a:xfrm>
+          <a:prstGeom prst="rect">
+            <a:avLst/>
+          </a:prstGeom>
+          <a:noFill/>
+        </p:spPr>
+        <p:txBody>
+          <a:bodyPr wrap="none" lIns="0" rIns="0" tIns="0" bIns="0" anchor="t">
+            <a:spAutoFit/>
+          </a:bodyPr>
+          <a:lstStyle/>
+          <a:p>
+            <a:pPr algn="l"/>
+            <a:r>
+              <a:rPr sz="691" b="0">
+                <a:solidFill>
+                  <a:srgbClr val="6F6963"/>
+                </a:solidFill>
+                <a:latin typeface="Arial"/>
+              </a:rPr>
+              <a:t>DIVISION</a:t>
+            </a:r>
+          </a:p>
+        </p:txBody>
+      </p:sp>
+      <p:sp>
+        <p:nvSpPr>
+          <p:cNvPr id="12" name="TextBox 11"/>
+          <p:cNvSpPr txBox="1"/>
+          <p:nvPr/>
+        </p:nvSpPr>
+        <p:spPr>
+          <a:xfrm>
+            <a:off x="561975" y="4039076"/>
+            <a:ext cx="1819423" cy="142875"/>
+          </a:xfrm>
+          <a:prstGeom prst="rect">
+            <a:avLst/>
+          </a:prstGeom>
+          <a:noFill/>
+        </p:spPr>
+        <p:txBody>
+          <a:bodyPr wrap="none" lIns="0" rIns="0" tIns="0" bIns="0" anchor="t">
+            <a:spAutoFit/>
+          </a:bodyPr>
+          <a:lstStyle/>
+          <a:p>
+            <a:pPr algn="l"/>
+            <a:r>
+              <a:rPr sz="945" b="0">
+                <a:solidFill>
+                  <a:srgbClr val="F4F1EE"/>
+                </a:solidFill>
+                <a:latin typeface="Arial"/>
+              </a:rPr>
+              <a:t>Marketing </a:t>
+            </a:r>
+            <a:r>
+              <a:rPr sz="945" b="0">
+                <a:solidFill>
+                  <a:srgbClr val="F4F1EE"/>
+                </a:solidFill>
+                <a:latin typeface="Arial"/>
+              </a:rPr>
+              <a:t>Unit </a:t>
+            </a:r>
+            <a:r>
+              <a:rPr sz="945" b="0">
+                <a:solidFill>
+                  <a:srgbClr val="F4F1EE"/>
+                </a:solidFill>
+                <a:latin typeface="Arial"/>
+              </a:rPr>
+              <a:t>&amp; </a:t>
+            </a:r>
+            <a:r>
+              <a:rPr sz="945" b="0">
+                <a:solidFill>
+                  <a:srgbClr val="F4F1EE"/>
+                </a:solidFill>
+                <a:latin typeface="Arial"/>
+              </a:rPr>
+              <a:t>Strategic</a:t>
+            </a:r>
+          </a:p>
+        </p:txBody>
+      </p:sp>
+      <p:sp>
+        <p:nvSpPr>
+          <p:cNvPr id="13" name="TextBox 12"/>
+          <p:cNvSpPr txBox="1"/>
+          <p:nvPr/>
+        </p:nvSpPr>
+        <p:spPr>
+          <a:xfrm>
+            <a:off x="561975" y="4638032"/>
+            <a:ext cx="975717" cy="104775"/>
+          </a:xfrm>
+          <a:prstGeom prst="rect">
+            <a:avLst/>
+          </a:prstGeom>
+          <a:noFill/>
+        </p:spPr>
+        <p:txBody>
+          <a:bodyPr wrap="none" lIns="0" rIns="0" tIns="0" bIns="0" anchor="t">
+            <a:spAutoFit/>
+          </a:bodyPr>
+          <a:lstStyle/>
+          <a:p>
+            <a:pPr algn="l"/>
+            <a:r>
+              <a:rPr sz="691" b="0">
+                <a:solidFill>
+                  <a:srgbClr val="6F6963"/>
+                </a:solidFill>
+                <a:latin typeface="Arial"/>
+              </a:rPr>
+              <a:t>PRODUCTS</a:t>
+            </a:r>
+          </a:p>
+        </p:txBody>
+      </p:sp>
+      <p:sp>
+        <p:nvSpPr>
+          <p:cNvPr id="14" name="TextBox 13"/>
+          <p:cNvSpPr txBox="1"/>
+          <p:nvPr/>
+        </p:nvSpPr>
+        <p:spPr>
+          <a:xfrm>
+            <a:off x="561975" y="4739759"/>
+            <a:ext cx="1970782" cy="142875"/>
+          </a:xfrm>
+          <a:prstGeom prst="rect">
+            <a:avLst/>
+          </a:prstGeom>
+          <a:noFill/>
+        </p:spPr>
+        <p:txBody>
+          <a:bodyPr wrap="none" lIns="0" rIns="0" tIns="0" bIns="0" anchor="t">
+            <a:spAutoFit/>
+          </a:bodyPr>
+          <a:lstStyle/>
+          <a:p>
+            <a:pPr algn="l"/>
+            <a:r>
+              <a:rPr sz="945" b="0">
+                <a:solidFill>
+                  <a:srgbClr val="F4F1EE"/>
+                </a:solidFill>
+                <a:latin typeface="Arial"/>
+              </a:rPr>
+              <a:t>Small </a:t>
+            </a:r>
+            <a:r>
+              <a:rPr sz="945" b="0">
+                <a:solidFill>
+                  <a:srgbClr val="F4F1EE"/>
+                </a:solidFill>
+                <a:latin typeface="Arial"/>
+              </a:rPr>
+              <a:t>Suppeq </a:t>
+            </a:r>
+            <a:r>
+              <a:rPr sz="945" b="0">
+                <a:solidFill>
+                  <a:srgbClr val="F4F1EE"/>
+                </a:solidFill>
+                <a:latin typeface="Arial"/>
+              </a:rPr>
+              <a:t>· </a:t>
+            </a:r>
+            <a:r>
+              <a:rPr sz="945" b="0">
+                <a:solidFill>
+                  <a:srgbClr val="F4F1EE"/>
+                </a:solidFill>
+                <a:latin typeface="Arial"/>
+              </a:rPr>
+              <a:t>Truck </a:t>
+            </a:r>
+            <a:r>
+              <a:rPr sz="945" b="0">
+                <a:solidFill>
+                  <a:srgbClr val="F4F1EE"/>
+                </a:solidFill>
+                <a:latin typeface="Arial"/>
+              </a:rPr>
+              <a:t>Others</a:t>
+            </a:r>
+          </a:p>
+        </p:txBody>
+      </p:sp>
+      <p:sp>
+        <p:nvSpPr>
+          <p:cNvPr id="15" name="TextBox 14"/>
+          <p:cNvSpPr txBox="1"/>
+          <p:nvPr/>
+        </p:nvSpPr>
+        <p:spPr>
+          <a:xfrm>
+            <a:off x="561975" y="5338714"/>
+            <a:ext cx="1625649" cy="104775"/>
+          </a:xfrm>
+          <a:prstGeom prst="rect">
+            <a:avLst/>
+          </a:prstGeom>
+          <a:noFill/>
+        </p:spPr>
+        <p:txBody>
+          <a:bodyPr wrap="none" lIns="0" rIns="0" tIns="0" bIns="0" anchor="t">
+            <a:spAutoFit/>
+          </a:bodyPr>
+          <a:lstStyle/>
+          <a:p>
+            <a:pPr algn="l"/>
+            <a:r>
+              <a:rPr sz="691" b="0">
+                <a:solidFill>
+                  <a:srgbClr val="6F6963"/>
+                </a:solidFill>
+                <a:latin typeface="Arial"/>
+              </a:rPr>
+              <a:t>PLACE, </a:t>
+            </a:r>
+            <a:r>
+              <a:rPr sz="691" b="0">
+                <a:solidFill>
+                  <a:srgbClr val="6F6963"/>
+                </a:solidFill>
+                <a:latin typeface="Arial"/>
+              </a:rPr>
+              <a:t>DATE </a:t>
+            </a:r>
+            <a:r>
+              <a:rPr sz="691" b="0">
+                <a:solidFill>
+                  <a:srgbClr val="6F6963"/>
+                </a:solidFill>
+                <a:latin typeface="Arial"/>
+              </a:rPr>
+              <a:t>OF </a:t>
+            </a:r>
+            <a:r>
+              <a:rPr sz="691" b="0">
+                <a:solidFill>
+                  <a:srgbClr val="6F6963"/>
+                </a:solidFill>
+                <a:latin typeface="Arial"/>
+              </a:rPr>
+              <a:t>BIRTH</a:t>
+            </a:r>
+          </a:p>
+        </p:txBody>
+      </p:sp>
+      <p:sp>
+        <p:nvSpPr>
+          <p:cNvPr id="16" name="TextBox 15"/>
+          <p:cNvSpPr txBox="1"/>
+          <p:nvPr/>
+        </p:nvSpPr>
+        <p:spPr>
+          <a:xfrm>
+            <a:off x="561975" y="5440441"/>
+            <a:ext cx="1599604" cy="142875"/>
+          </a:xfrm>
+          <a:prstGeom prst="rect">
+            <a:avLst/>
+          </a:prstGeom>
+          <a:noFill/>
+        </p:spPr>
+        <p:txBody>
+          <a:bodyPr wrap="none" lIns="0" rIns="0" tIns="0" bIns="0" anchor="t">
+            <a:spAutoFit/>
+          </a:bodyPr>
+          <a:lstStyle/>
+          <a:p>
+            <a:pPr algn="l"/>
+            <a:r>
+              <a:rPr sz="945" b="0">
+                <a:solidFill>
+                  <a:srgbClr val="F4F1EE"/>
+                </a:solidFill>
+                <a:latin typeface="Arial"/>
+              </a:rPr>
+              <a:t>Kupang, </a:t>
+            </a:r>
+            <a:r>
+              <a:rPr sz="945" b="0">
+                <a:solidFill>
+                  <a:srgbClr val="F4F1EE"/>
+                </a:solidFill>
+                <a:latin typeface="Arial"/>
+              </a:rPr>
+              <a:t>22 </a:t>
+            </a:r>
+            <a:r>
+              <a:rPr sz="945" b="0">
+                <a:solidFill>
+                  <a:srgbClr val="F4F1EE"/>
+                </a:solidFill>
+                <a:latin typeface="Arial"/>
+              </a:rPr>
+              <a:t>April </a:t>
+            </a:r>
+            <a:r>
+              <a:rPr sz="945" b="0">
+                <a:solidFill>
+                  <a:srgbClr val="F4F1EE"/>
+                </a:solidFill>
+                <a:latin typeface="Arial"/>
+              </a:rPr>
+              <a:t>2001</a:t>
+            </a:r>
+          </a:p>
+        </p:txBody>
+      </p:sp>
+      <p:sp>
+        <p:nvSpPr>
+          <p:cNvPr id="17" name="TextBox 16"/>
+          <p:cNvSpPr txBox="1"/>
+          <p:nvPr/>
+        </p:nvSpPr>
+        <p:spPr>
+          <a:xfrm>
+            <a:off x="561975" y="6039397"/>
+            <a:ext cx="757088" cy="104775"/>
+          </a:xfrm>
+          <a:prstGeom prst="rect">
+            <a:avLst/>
+          </a:prstGeom>
+          <a:noFill/>
+        </p:spPr>
+        <p:txBody>
+          <a:bodyPr wrap="none" lIns="0" rIns="0" tIns="0" bIns="0" anchor="t">
+            <a:spAutoFit/>
+          </a:bodyPr>
+          <a:lstStyle/>
+          <a:p>
+            <a:pPr algn="l"/>
+            <a:r>
+              <a:rPr sz="691" b="0">
+                <a:solidFill>
+                  <a:srgbClr val="6F6963"/>
+                </a:solidFill>
+                <a:latin typeface="Arial"/>
+              </a:rPr>
+              <a:t>PHONE</a:t>
+            </a:r>
+          </a:p>
+        </p:txBody>
+      </p:sp>
+      <p:sp>
+        <p:nvSpPr>
+          <p:cNvPr id="18" name="TextBox 17"/>
+          <p:cNvSpPr txBox="1"/>
+          <p:nvPr/>
+        </p:nvSpPr>
+        <p:spPr>
+          <a:xfrm>
+            <a:off x="561975" y="6141124"/>
+            <a:ext cx="1276201" cy="142875"/>
+          </a:xfrm>
+          <a:prstGeom prst="rect">
+            <a:avLst/>
+          </a:prstGeom>
+          <a:noFill/>
+        </p:spPr>
+        <p:txBody>
+          <a:bodyPr wrap="none" lIns="0" rIns="0" tIns="0" bIns="0" anchor="t">
+            <a:spAutoFit/>
+          </a:bodyPr>
+          <a:lstStyle/>
+          <a:p>
+            <a:pPr algn="l"/>
+            <a:r>
+              <a:rPr sz="945" b="0">
+                <a:solidFill>
+                  <a:srgbClr val="F4F1EE"/>
+                </a:solidFill>
+                <a:latin typeface="Arial"/>
+              </a:rPr>
+              <a:t>0822 </a:t>
+            </a:r>
+            <a:r>
+              <a:rPr sz="945" b="0">
+                <a:solidFill>
+                  <a:srgbClr val="F4F1EE"/>
+                </a:solidFill>
+                <a:latin typeface="Arial"/>
+              </a:rPr>
+              <a:t>7222 </a:t>
+            </a:r>
+            <a:r>
+              <a:rPr sz="945" b="0">
+                <a:solidFill>
+                  <a:srgbClr val="F4F1EE"/>
+                </a:solidFill>
+                <a:latin typeface="Arial"/>
+              </a:rPr>
+              <a:t>2463</a:t>
+            </a:r>
+          </a:p>
+        </p:txBody>
+      </p:sp>
+      <p:sp>
+        <p:nvSpPr>
+          <p:cNvPr id="19" name="TextBox 18"/>
+          <p:cNvSpPr txBox="1"/>
+          <p:nvPr/>
+        </p:nvSpPr>
+        <p:spPr>
+          <a:xfrm>
+            <a:off x="3948261" y="1522857"/>
+            <a:ext cx="956518" cy="133350"/>
+          </a:xfrm>
+          <a:prstGeom prst="rect">
+            <a:avLst/>
+          </a:prstGeom>
+          <a:noFill/>
+        </p:spPr>
+        <p:txBody>
+          <a:bodyPr wrap="none" lIns="0" rIns="0" tIns="0" bIns="0" anchor="t">
+            <a:spAutoFit/>
+          </a:bodyPr>
+          <a:lstStyle/>
+          <a:p>
+            <a:pPr algn="l"/>
+            <a:r>
+              <a:rPr sz="909" b="1">
+                <a:solidFill>
+                  <a:srgbClr val="F4F1EE"/>
+                </a:solidFill>
+                <a:latin typeface="Arial"/>
+              </a:rPr>
+              <a:t>Education</a:t>
+            </a:r>
+          </a:p>
+        </p:txBody>
+      </p:sp>
+      <p:sp>
+        <p:nvSpPr>
+          <p:cNvPr id="20" name="TextBox 19"/>
+          <p:cNvSpPr txBox="1"/>
+          <p:nvPr/>
+        </p:nvSpPr>
+        <p:spPr>
+          <a:xfrm>
+            <a:off x="4767411" y="1892808"/>
+            <a:ext cx="2888753" cy="152400"/>
+          </a:xfrm>
+          <a:prstGeom prst="rect">
+            <a:avLst/>
+          </a:prstGeom>
+          <a:noFill/>
+        </p:spPr>
+        <p:txBody>
+          <a:bodyPr wrap="none" lIns="0" rIns="0" tIns="0" bIns="0" anchor="t">
+            <a:spAutoFit/>
+          </a:bodyPr>
+          <a:lstStyle/>
+          <a:p>
+            <a:pPr algn="l"/>
+            <a:r>
+              <a:rPr sz="1018" b="1">
+                <a:solidFill>
+                  <a:srgbClr val="F4F1EE"/>
+                </a:solidFill>
+                <a:latin typeface="Arial"/>
+              </a:rPr>
+              <a:t>Universitas </a:t>
+            </a:r>
+            <a:r>
+              <a:rPr sz="1018" b="1">
+                <a:solidFill>
+                  <a:srgbClr val="F4F1EE"/>
+                </a:solidFill>
+                <a:latin typeface="Arial"/>
+              </a:rPr>
+              <a:t>Sanata </a:t>
+            </a:r>
+            <a:r>
+              <a:rPr sz="1018" b="1">
+                <a:solidFill>
+                  <a:srgbClr val="F4F1EE"/>
+                </a:solidFill>
+                <a:latin typeface="Arial"/>
+              </a:rPr>
+              <a:t>Dharma, </a:t>
+            </a:r>
+            <a:r>
+              <a:rPr sz="1018" b="1">
+                <a:solidFill>
+                  <a:srgbClr val="F4F1EE"/>
+                </a:solidFill>
+                <a:latin typeface="Arial"/>
+              </a:rPr>
+              <a:t>Yogyakarta</a:t>
+            </a:r>
+          </a:p>
+        </p:txBody>
+      </p:sp>
+      <p:sp>
+        <p:nvSpPr>
+          <p:cNvPr id="21" name="TextBox 20"/>
+          <p:cNvSpPr txBox="1"/>
+          <p:nvPr/>
+        </p:nvSpPr>
+        <p:spPr>
+          <a:xfrm>
+            <a:off x="4767411" y="2046732"/>
+            <a:ext cx="3036391" cy="133350"/>
+          </a:xfrm>
+          <a:prstGeom prst="rect">
+            <a:avLst/>
+          </a:prstGeom>
+          <a:noFill/>
+        </p:spPr>
+        <p:txBody>
+          <a:bodyPr wrap="none" lIns="0" rIns="0" tIns="0" bIns="0" anchor="t">
+            <a:spAutoFit/>
+          </a:bodyPr>
+          <a:lstStyle/>
+          <a:p>
+            <a:pPr algn="l"/>
+            <a:r>
+              <a:rPr sz="873" b="0">
+                <a:solidFill>
+                  <a:srgbClr val="A9A29C"/>
+                </a:solidFill>
+                <a:latin typeface="Arial"/>
+              </a:rPr>
+              <a:t>Bachelor </a:t>
+            </a:r>
+            <a:r>
+              <a:rPr sz="873" b="0">
+                <a:solidFill>
+                  <a:srgbClr val="A9A29C"/>
+                </a:solidFill>
+                <a:latin typeface="Arial"/>
+              </a:rPr>
+              <a:t>(S1) </a:t>
+            </a:r>
+            <a:r>
+              <a:rPr sz="873" b="0">
+                <a:solidFill>
+                  <a:srgbClr val="A9A29C"/>
+                </a:solidFill>
+                <a:latin typeface="Arial"/>
+              </a:rPr>
+              <a:t>· </a:t>
+            </a:r>
+            <a:r>
+              <a:rPr sz="873" b="0">
+                <a:solidFill>
+                  <a:srgbClr val="A9A29C"/>
+                </a:solidFill>
+                <a:latin typeface="Arial"/>
+              </a:rPr>
+              <a:t>Management </a:t>
+            </a:r>
+            <a:r>
+              <a:rPr sz="873" b="0">
+                <a:solidFill>
+                  <a:srgbClr val="A9A29C"/>
+                </a:solidFill>
+                <a:latin typeface="Arial"/>
+              </a:rPr>
+              <a:t>· </a:t>
+            </a:r>
+            <a:r>
+              <a:rPr sz="873" b="0">
+                <a:solidFill>
+                  <a:srgbClr val="A9A29C"/>
+                </a:solidFill>
+                <a:latin typeface="Arial"/>
+              </a:rPr>
+              <a:t>Faculty </a:t>
+            </a:r>
+            <a:r>
+              <a:rPr sz="873" b="0">
+                <a:solidFill>
+                  <a:srgbClr val="A9A29C"/>
+                </a:solidFill>
+                <a:latin typeface="Arial"/>
+              </a:rPr>
+              <a:t>of </a:t>
+            </a:r>
+            <a:r>
+              <a:rPr sz="873" b="0">
+                <a:solidFill>
+                  <a:srgbClr val="A9A29C"/>
+                </a:solidFill>
+                <a:latin typeface="Arial"/>
+              </a:rPr>
+              <a:t>Economics</a:t>
+            </a:r>
+          </a:p>
+        </p:txBody>
+      </p:sp>
+      <p:sp>
+        <p:nvSpPr>
+          <p:cNvPr id="22" name="TextBox 21"/>
+          <p:cNvSpPr txBox="1"/>
+          <p:nvPr/>
+        </p:nvSpPr>
+        <p:spPr>
+          <a:xfrm>
+            <a:off x="3948261" y="2773013"/>
+            <a:ext cx="1344959" cy="133350"/>
+          </a:xfrm>
+          <a:prstGeom prst="rect">
+            <a:avLst/>
+          </a:prstGeom>
+          <a:noFill/>
+        </p:spPr>
+        <p:txBody>
+          <a:bodyPr wrap="none" lIns="0" rIns="0" tIns="0" bIns="0" anchor="t">
+            <a:spAutoFit/>
+          </a:bodyPr>
+          <a:lstStyle/>
+          <a:p>
+            <a:pPr algn="l"/>
+            <a:r>
+              <a:rPr sz="909" b="1">
+                <a:solidFill>
+                  <a:srgbClr val="F4F1EE"/>
+                </a:solidFill>
+                <a:latin typeface="Arial"/>
+              </a:rPr>
+              <a:t>Work </a:t>
+            </a:r>
+            <a:r>
+              <a:rPr sz="909" b="1">
+                <a:solidFill>
+                  <a:srgbClr val="F4F1EE"/>
+                </a:solidFill>
+                <a:latin typeface="Arial"/>
+              </a:rPr>
+              <a:t>Experience</a:t>
+            </a:r>
+          </a:p>
+        </p:txBody>
+      </p:sp>
+      <p:sp>
+        <p:nvSpPr>
+          <p:cNvPr id="23" name="TextBox 22"/>
+          <p:cNvSpPr txBox="1"/>
+          <p:nvPr/>
+        </p:nvSpPr>
+        <p:spPr>
+          <a:xfrm>
+            <a:off x="4767411" y="3300126"/>
+            <a:ext cx="2122735" cy="152400"/>
+          </a:xfrm>
+          <a:prstGeom prst="rect">
+            <a:avLst/>
+          </a:prstGeom>
+          <a:noFill/>
+        </p:spPr>
+        <p:txBody>
+          <a:bodyPr wrap="none" lIns="0" rIns="0" tIns="0" bIns="0" anchor="t">
+            <a:spAutoFit/>
+          </a:bodyPr>
+          <a:lstStyle/>
+          <a:p>
+            <a:pPr algn="l"/>
+            <a:r>
+              <a:rPr sz="1018" b="1">
+                <a:solidFill>
+                  <a:srgbClr val="F4F1EE"/>
+                </a:solidFill>
+                <a:latin typeface="Arial"/>
+              </a:rPr>
+              <a:t>PT </a:t>
+            </a:r>
+            <a:r>
+              <a:rPr sz="1018" b="1">
+                <a:solidFill>
+                  <a:srgbClr val="F4F1EE"/>
+                </a:solidFill>
+                <a:latin typeface="Arial"/>
+              </a:rPr>
+              <a:t>Triatra </a:t>
+            </a:r>
+            <a:r>
+              <a:rPr sz="1018" b="1">
+                <a:solidFill>
+                  <a:srgbClr val="F4F1EE"/>
+                </a:solidFill>
+                <a:latin typeface="Arial"/>
+              </a:rPr>
+              <a:t>Sinergia </a:t>
+            </a:r>
+            <a:r>
+              <a:rPr sz="1018" b="1">
+                <a:solidFill>
+                  <a:srgbClr val="F4F1EE"/>
+                </a:solidFill>
+                <a:latin typeface="Arial"/>
+              </a:rPr>
+              <a:t>Pratama</a:t>
+            </a:r>
+          </a:p>
+        </p:txBody>
+      </p:sp>
+      <p:sp>
+        <p:nvSpPr>
+          <p:cNvPr id="24" name="TextBox 23"/>
+          <p:cNvSpPr txBox="1"/>
+          <p:nvPr/>
+        </p:nvSpPr>
+        <p:spPr>
+          <a:xfrm>
+            <a:off x="4767411" y="3454050"/>
+            <a:ext cx="1982092" cy="133350"/>
+          </a:xfrm>
+          <a:prstGeom prst="rect">
+            <a:avLst/>
+          </a:prstGeom>
+          <a:noFill/>
+        </p:spPr>
+        <p:txBody>
+          <a:bodyPr wrap="none" lIns="0" rIns="0" tIns="0" bIns="0" anchor="t">
+            <a:spAutoFit/>
+          </a:bodyPr>
+          <a:lstStyle/>
+          <a:p>
+            <a:pPr algn="l"/>
+            <a:r>
+              <a:rPr sz="873" b="0">
+                <a:solidFill>
+                  <a:srgbClr val="A9A29C"/>
+                </a:solidFill>
+                <a:latin typeface="Arial"/>
+              </a:rPr>
+              <a:t>Marketing </a:t>
+            </a:r>
+            <a:r>
+              <a:rPr sz="873" b="0">
+                <a:solidFill>
+                  <a:srgbClr val="A9A29C"/>
+                </a:solidFill>
+                <a:latin typeface="Arial"/>
+              </a:rPr>
+              <a:t>Strategic </a:t>
+            </a:r>
+            <a:r>
+              <a:rPr sz="873" b="0">
+                <a:solidFill>
+                  <a:srgbClr val="A9A29C"/>
+                </a:solidFill>
+                <a:latin typeface="Arial"/>
+              </a:rPr>
+              <a:t>2 </a:t>
+            </a:r>
+            <a:r>
+              <a:rPr sz="873" b="0">
+                <a:solidFill>
+                  <a:srgbClr val="A9A29C"/>
+                </a:solidFill>
+                <a:latin typeface="Arial"/>
+              </a:rPr>
+              <a:t>Associate</a:t>
+            </a:r>
+          </a:p>
+        </p:txBody>
+      </p:sp>
+      <p:sp>
+        <p:nvSpPr>
+          <p:cNvPr id="25" name="TextBox 24"/>
+          <p:cNvSpPr txBox="1"/>
+          <p:nvPr/>
+        </p:nvSpPr>
+        <p:spPr>
+          <a:xfrm>
+            <a:off x="7692479" y="3377850"/>
+            <a:ext cx="990897" cy="133350"/>
+          </a:xfrm>
+          <a:prstGeom prst="rect">
+            <a:avLst/>
+          </a:prstGeom>
+          <a:noFill/>
+        </p:spPr>
+        <p:txBody>
+          <a:bodyPr wrap="none" lIns="0" rIns="0" tIns="0" bIns="0" anchor="t">
+            <a:spAutoFit/>
+          </a:bodyPr>
+          <a:lstStyle/>
+          <a:p>
+            <a:pPr algn="l"/>
+            <a:r>
+              <a:rPr sz="873" b="1">
+                <a:solidFill>
+                  <a:srgbClr val="F0ECE8"/>
+                </a:solidFill>
+                <a:latin typeface="Arial"/>
+              </a:rPr>
+              <a:t>2026 </a:t>
+            </a:r>
+            <a:r>
+              <a:rPr sz="873" b="1">
+                <a:solidFill>
+                  <a:srgbClr val="F0ECE8"/>
+                </a:solidFill>
+                <a:latin typeface="Arial"/>
+              </a:rPr>
+              <a:t>– </a:t>
+            </a:r>
+            <a:r>
+              <a:rPr sz="873" b="1">
+                <a:solidFill>
+                  <a:srgbClr val="F0ECE8"/>
+                </a:solidFill>
+                <a:latin typeface="Arial"/>
+              </a:rPr>
+              <a:t>now</a:t>
+            </a:r>
+          </a:p>
+        </p:txBody>
+      </p:sp>
+      <p:sp>
+        <p:nvSpPr>
+          <p:cNvPr id="26" name="TextBox 25"/>
+          <p:cNvSpPr txBox="1"/>
+          <p:nvPr/>
+        </p:nvSpPr>
+        <p:spPr>
+          <a:xfrm>
+            <a:off x="4767411" y="4047839"/>
+            <a:ext cx="810815" cy="152400"/>
+          </a:xfrm>
+          <a:prstGeom prst="rect">
+            <a:avLst/>
+          </a:prstGeom>
+          <a:noFill/>
+        </p:spPr>
+        <p:txBody>
+          <a:bodyPr wrap="none" lIns="0" rIns="0" tIns="0" bIns="0" anchor="t">
+            <a:spAutoFit/>
+          </a:bodyPr>
+          <a:lstStyle/>
+          <a:p>
+            <a:pPr algn="l"/>
+            <a:r>
+              <a:rPr sz="1018" b="1">
+                <a:solidFill>
+                  <a:srgbClr val="F4F1EE"/>
+                </a:solidFill>
+                <a:latin typeface="Arial"/>
+              </a:rPr>
+              <a:t>Outlier</a:t>
+            </a:r>
+          </a:p>
+        </p:txBody>
+      </p:sp>
+      <p:sp>
+        <p:nvSpPr>
+          <p:cNvPr id="27" name="TextBox 26"/>
+          <p:cNvSpPr txBox="1"/>
+          <p:nvPr/>
+        </p:nvSpPr>
+        <p:spPr>
+          <a:xfrm>
+            <a:off x="4767411" y="4201763"/>
+            <a:ext cx="1740842" cy="133350"/>
+          </a:xfrm>
+          <a:prstGeom prst="rect">
+            <a:avLst/>
+          </a:prstGeom>
+          <a:noFill/>
+        </p:spPr>
+        <p:txBody>
+          <a:bodyPr wrap="none" lIns="0" rIns="0" tIns="0" bIns="0" anchor="t">
+            <a:spAutoFit/>
+          </a:bodyPr>
+          <a:lstStyle/>
+          <a:p>
+            <a:pPr algn="l"/>
+            <a:r>
+              <a:rPr sz="873" b="0">
+                <a:solidFill>
+                  <a:srgbClr val="A9A29C"/>
+                </a:solidFill>
+                <a:latin typeface="Arial"/>
+              </a:rPr>
+              <a:t>Team </a:t>
+            </a:r>
+            <a:r>
+              <a:rPr sz="873" b="0">
+                <a:solidFill>
+                  <a:srgbClr val="A9A29C"/>
+                </a:solidFill>
+                <a:latin typeface="Arial"/>
+              </a:rPr>
+              <a:t>Lead </a:t>
+            </a:r>
+            <a:r>
+              <a:rPr sz="873" b="0">
+                <a:solidFill>
+                  <a:srgbClr val="A9A29C"/>
+                </a:solidFill>
+                <a:latin typeface="Arial"/>
+              </a:rPr>
+              <a:t>Data </a:t>
+            </a:r>
+            <a:r>
+              <a:rPr sz="873" b="0">
+                <a:solidFill>
+                  <a:srgbClr val="A9A29C"/>
+                </a:solidFill>
+                <a:latin typeface="Arial"/>
+              </a:rPr>
+              <a:t>Annotator</a:t>
+            </a:r>
+          </a:p>
+        </p:txBody>
+      </p:sp>
+      <p:sp>
+        <p:nvSpPr>
+          <p:cNvPr id="28" name="TextBox 27"/>
+          <p:cNvSpPr txBox="1"/>
+          <p:nvPr/>
+        </p:nvSpPr>
+        <p:spPr>
+          <a:xfrm>
+            <a:off x="7666732" y="4125563"/>
+            <a:ext cx="1016644" cy="133350"/>
+          </a:xfrm>
+          <a:prstGeom prst="rect">
+            <a:avLst/>
+          </a:prstGeom>
+          <a:noFill/>
+        </p:spPr>
+        <p:txBody>
+          <a:bodyPr wrap="none" lIns="0" rIns="0" tIns="0" bIns="0" anchor="t">
+            <a:spAutoFit/>
+          </a:bodyPr>
+          <a:lstStyle/>
+          <a:p>
+            <a:pPr algn="l"/>
+            <a:r>
+              <a:rPr sz="873" b="1">
                 <a:solidFill>
                   <a:srgbClr val="FF5A1F"/>
                 </a:solidFill>
                 <a:latin typeface="Arial"/>
               </a:rPr>
-              <a:t>Strategic </a:t>
-            </a:r>
-            <a:r>
-              <a:rPr sz="1164" b="1">
+              <a:t>2023 </a:t>
+            </a:r>
+            <a:r>
+              <a:rPr sz="873" b="1">
                 <a:solidFill>
                   <a:srgbClr val="FF5A1F"/>
                 </a:solidFill>
                 <a:latin typeface="Arial"/>
               </a:rPr>
-              <a:t>2 </a:t>
-            </a:r>
-            <a:r>
-              <a:rPr sz="1164" b="1">
+              <a:t>– </a:t>
+            </a:r>
+            <a:r>
+              <a:rPr sz="873" b="1">
                 <a:solidFill>
                   <a:srgbClr val="FF5A1F"/>
                 </a:solidFill>
                 <a:latin typeface="Arial"/>
               </a:rPr>
-              <a:t>Associate</a:t>
-            </a:r>
-          </a:p>
-        </p:txBody>
-      </p:sp>
-      <p:sp>
-        <p:nvSpPr>
-          <p:cNvPr id="8" name="TextBox 7"/>
-          <p:cNvSpPr txBox="1"/>
-          <p:nvPr/>
-        </p:nvSpPr>
-        <p:spPr>
-          <a:xfrm>
-            <a:off x="561975" y="2144268"/>
-            <a:ext cx="900261" cy="104775"/>
-          </a:xfrm>
-          <a:prstGeom prst="rect">
-            <a:avLst/>
-          </a:prstGeom>
-          <a:noFill/>
-        </p:spPr>
-        <p:txBody>
-          <a:bodyPr wrap="none" lIns="0" rIns="0" tIns="0" bIns="0" anchor="t">
-            <a:spAutoFit/>
-          </a:bodyPr>
-          <a:lstStyle/>
-          <a:p>
-            <a:pPr algn="l"/>
-            <a:r>
-              <a:rPr sz="691" b="0">
-                <a:solidFill>
-                  <a:srgbClr val="6F6963"/>
-                </a:solidFill>
-                <a:latin typeface="Arial"/>
-              </a:rPr>
-              <a:t>POSITION</a:t>
-            </a:r>
-          </a:p>
-        </p:txBody>
-      </p:sp>
-      <p:sp>
-        <p:nvSpPr>
-          <p:cNvPr id="9" name="TextBox 8"/>
-          <p:cNvSpPr txBox="1"/>
-          <p:nvPr/>
-        </p:nvSpPr>
-        <p:spPr>
-          <a:xfrm>
-            <a:off x="561975" y="2245995"/>
-            <a:ext cx="2115442" cy="142875"/>
-          </a:xfrm>
-          <a:prstGeom prst="rect">
-            <a:avLst/>
-          </a:prstGeom>
-          <a:noFill/>
-        </p:spPr>
-        <p:txBody>
-          <a:bodyPr wrap="none" lIns="0" rIns="0" tIns="0" bIns="0" anchor="t">
-            <a:spAutoFit/>
-          </a:bodyPr>
-          <a:lstStyle/>
-          <a:p>
-            <a:pPr algn="l"/>
-            <a:r>
-              <a:rPr sz="945" b="0">
-                <a:solidFill>
-                  <a:srgbClr val="F4F1EE"/>
+              <a:t>2025</a:t>
+            </a:r>
+          </a:p>
+        </p:txBody>
+      </p:sp>
+      <p:sp>
+        <p:nvSpPr>
+          <p:cNvPr id="29" name="TextBox 28"/>
+          <p:cNvSpPr txBox="1"/>
+          <p:nvPr/>
+        </p:nvSpPr>
+        <p:spPr>
+          <a:xfrm>
+            <a:off x="4767411" y="4795551"/>
+            <a:ext cx="1751855" cy="152400"/>
+          </a:xfrm>
+          <a:prstGeom prst="rect">
+            <a:avLst/>
+          </a:prstGeom>
+          <a:noFill/>
+        </p:spPr>
+        <p:txBody>
+          <a:bodyPr wrap="none" lIns="0" rIns="0" tIns="0" bIns="0" anchor="t">
+            <a:spAutoFit/>
+          </a:bodyPr>
+          <a:lstStyle/>
+          <a:p>
+            <a:pPr algn="l"/>
+            <a:r>
+              <a:rPr sz="1018" b="1">
+                <a:solidFill>
+                  <a:srgbClr val="F4F1EE"/>
+                </a:solidFill>
+                <a:latin typeface="Arial"/>
+              </a:rPr>
+              <a:t>Krishma </a:t>
+            </a:r>
+            <a:r>
+              <a:rPr sz="1018" b="1">
+                <a:solidFill>
+                  <a:srgbClr val="F4F1EE"/>
+                </a:solidFill>
+                <a:latin typeface="Arial"/>
+              </a:rPr>
+              <a:t>International</a:t>
+            </a:r>
+          </a:p>
+        </p:txBody>
+      </p:sp>
+      <p:sp>
+        <p:nvSpPr>
+          <p:cNvPr id="30" name="TextBox 29"/>
+          <p:cNvSpPr txBox="1"/>
+          <p:nvPr/>
+        </p:nvSpPr>
+        <p:spPr>
+          <a:xfrm>
+            <a:off x="4767411" y="4949475"/>
+            <a:ext cx="1511944" cy="133350"/>
+          </a:xfrm>
+          <a:prstGeom prst="rect">
+            <a:avLst/>
+          </a:prstGeom>
+          <a:noFill/>
+        </p:spPr>
+        <p:txBody>
+          <a:bodyPr wrap="none" lIns="0" rIns="0" tIns="0" bIns="0" anchor="t">
+            <a:spAutoFit/>
+          </a:bodyPr>
+          <a:lstStyle/>
+          <a:p>
+            <a:pPr algn="l"/>
+            <a:r>
+              <a:rPr sz="873" b="0">
+                <a:solidFill>
+                  <a:srgbClr val="A9A29C"/>
                 </a:solidFill>
                 <a:latin typeface="Arial"/>
               </a:rPr>
               <a:t>Marketing </a:t>
             </a:r>
             <a:r>
-              <a:rPr sz="945" b="0">
-                <a:solidFill>
-                  <a:srgbClr val="F4F1EE"/>
-                </a:solidFill>
-                <a:latin typeface="Arial"/>
-              </a:rPr>
-              <a:t>Strategic </a:t>
-            </a:r>
-            <a:r>
-              <a:rPr sz="945" b="0">
-                <a:solidFill>
-                  <a:srgbClr val="F4F1EE"/>
-                </a:solidFill>
-                <a:latin typeface="Arial"/>
-              </a:rPr>
-              <a:t>2 </a:t>
-            </a:r>
-            <a:r>
-              <a:rPr sz="945" b="0">
-                <a:solidFill>
-                  <a:srgbClr val="F4F1EE"/>
-                </a:solidFill>
-                <a:latin typeface="Arial"/>
-              </a:rPr>
-              <a:t>Associate</a:t>
-            </a:r>
-          </a:p>
-        </p:txBody>
-      </p:sp>
-      <p:sp>
-        <p:nvSpPr>
-          <p:cNvPr id="10" name="TextBox 9"/>
-          <p:cNvSpPr txBox="1"/>
-          <p:nvPr/>
-        </p:nvSpPr>
-        <p:spPr>
-          <a:xfrm>
-            <a:off x="561975" y="2515743"/>
-            <a:ext cx="865137" cy="104775"/>
-          </a:xfrm>
-          <a:prstGeom prst="rect">
-            <a:avLst/>
-          </a:prstGeom>
-          <a:noFill/>
-        </p:spPr>
-        <p:txBody>
-          <a:bodyPr wrap="none" lIns="0" rIns="0" tIns="0" bIns="0" anchor="t">
-            <a:spAutoFit/>
-          </a:bodyPr>
-          <a:lstStyle/>
-          <a:p>
-            <a:pPr algn="l"/>
-            <a:r>
-              <a:rPr sz="691" b="0">
-                <a:solidFill>
-                  <a:srgbClr val="6F6963"/>
-                </a:solidFill>
-                <a:latin typeface="Arial"/>
-              </a:rPr>
-              <a:t>DIVISION</a:t>
-            </a:r>
-          </a:p>
-        </p:txBody>
-      </p:sp>
-      <p:sp>
-        <p:nvSpPr>
-          <p:cNvPr id="11" name="TextBox 10"/>
-          <p:cNvSpPr txBox="1"/>
-          <p:nvPr/>
-        </p:nvSpPr>
-        <p:spPr>
-          <a:xfrm>
-            <a:off x="561975" y="2617470"/>
-            <a:ext cx="3461891" cy="142875"/>
-          </a:xfrm>
-          <a:prstGeom prst="rect">
-            <a:avLst/>
-          </a:prstGeom>
-          <a:noFill/>
-        </p:spPr>
-        <p:txBody>
-          <a:bodyPr wrap="none" lIns="0" rIns="0" tIns="0" bIns="0" anchor="t">
-            <a:spAutoFit/>
-          </a:bodyPr>
-          <a:lstStyle/>
-          <a:p>
-            <a:pPr algn="l"/>
-            <a:r>
-              <a:rPr sz="945" b="0">
-                <a:solidFill>
-                  <a:srgbClr val="F4F1EE"/>
-                </a:solidFill>
-                <a:latin typeface="Arial"/>
-              </a:rPr>
-              <a:t>Marketing </a:t>
-            </a:r>
-            <a:r>
-              <a:rPr sz="945" b="0">
-                <a:solidFill>
-                  <a:srgbClr val="F4F1EE"/>
-                </a:solidFill>
-                <a:latin typeface="Arial"/>
-              </a:rPr>
-              <a:t>Unit </a:t>
-            </a:r>
-            <a:r>
-              <a:rPr sz="945" b="0">
-                <a:solidFill>
-                  <a:srgbClr val="F4F1EE"/>
-                </a:solidFill>
-                <a:latin typeface="Arial"/>
-              </a:rPr>
-              <a:t>&amp; </a:t>
-            </a:r>
-            <a:r>
-              <a:rPr sz="945" b="0">
-                <a:solidFill>
-                  <a:srgbClr val="F4F1EE"/>
-                </a:solidFill>
-                <a:latin typeface="Arial"/>
-              </a:rPr>
-              <a:t>Strategic </a:t>
-            </a:r>
-            <a:r>
-              <a:rPr sz="945" b="0">
-                <a:solidFill>
-                  <a:srgbClr val="F4F1EE"/>
-                </a:solidFill>
-                <a:latin typeface="Arial"/>
-              </a:rPr>
-              <a:t>· </a:t>
-            </a:r>
-            <a:r>
-              <a:rPr sz="945" b="0">
-                <a:solidFill>
-                  <a:srgbClr val="F4F1EE"/>
-                </a:solidFill>
-                <a:latin typeface="Arial"/>
-              </a:rPr>
-              <a:t>PT </a:t>
-            </a:r>
-            <a:r>
-              <a:rPr sz="945" b="0">
-                <a:solidFill>
-                  <a:srgbClr val="F4F1EE"/>
-                </a:solidFill>
-                <a:latin typeface="Arial"/>
-              </a:rPr>
-              <a:t>Triatra </a:t>
-            </a:r>
-            <a:r>
-              <a:rPr sz="945" b="0">
-                <a:solidFill>
-                  <a:srgbClr val="F4F1EE"/>
-                </a:solidFill>
-                <a:latin typeface="Arial"/>
-              </a:rPr>
-              <a:t>Sinergia </a:t>
-            </a:r>
-            <a:r>
-              <a:rPr sz="945" b="0">
-                <a:solidFill>
-                  <a:srgbClr val="F4F1EE"/>
-                </a:solidFill>
-                <a:latin typeface="Arial"/>
-              </a:rPr>
-              <a:t>Pratama</a:t>
-            </a:r>
-          </a:p>
-        </p:txBody>
-      </p:sp>
-      <p:sp>
-        <p:nvSpPr>
-          <p:cNvPr id="12" name="TextBox 11"/>
-          <p:cNvSpPr txBox="1"/>
-          <p:nvPr/>
-        </p:nvSpPr>
-        <p:spPr>
-          <a:xfrm>
-            <a:off x="561975" y="2887218"/>
-            <a:ext cx="975717" cy="104775"/>
-          </a:xfrm>
-          <a:prstGeom prst="rect">
-            <a:avLst/>
-          </a:prstGeom>
-          <a:noFill/>
-        </p:spPr>
-        <p:txBody>
-          <a:bodyPr wrap="none" lIns="0" rIns="0" tIns="0" bIns="0" anchor="t">
-            <a:spAutoFit/>
-          </a:bodyPr>
-          <a:lstStyle/>
-          <a:p>
-            <a:pPr algn="l"/>
-            <a:r>
-              <a:rPr sz="691" b="0">
-                <a:solidFill>
-                  <a:srgbClr val="6F6963"/>
-                </a:solidFill>
-                <a:latin typeface="Arial"/>
-              </a:rPr>
-              <a:t>PRODUCTS</a:t>
-            </a:r>
-          </a:p>
-        </p:txBody>
-      </p:sp>
-      <p:sp>
-        <p:nvSpPr>
-          <p:cNvPr id="13" name="TextBox 12"/>
-          <p:cNvSpPr txBox="1"/>
-          <p:nvPr/>
-        </p:nvSpPr>
-        <p:spPr>
-          <a:xfrm>
-            <a:off x="561975" y="2988945"/>
-            <a:ext cx="1970782" cy="142875"/>
-          </a:xfrm>
-          <a:prstGeom prst="rect">
-            <a:avLst/>
-          </a:prstGeom>
-          <a:noFill/>
-        </p:spPr>
-        <p:txBody>
-          <a:bodyPr wrap="none" lIns="0" rIns="0" tIns="0" bIns="0" anchor="t">
-            <a:spAutoFit/>
-          </a:bodyPr>
-          <a:lstStyle/>
-          <a:p>
-            <a:pPr algn="l"/>
-            <a:r>
-              <a:rPr sz="945" b="0">
-                <a:solidFill>
-                  <a:srgbClr val="F4F1EE"/>
-                </a:solidFill>
-                <a:latin typeface="Arial"/>
-              </a:rPr>
-              <a:t>Small </a:t>
-            </a:r>
-            <a:r>
-              <a:rPr sz="945" b="0">
-                <a:solidFill>
-                  <a:srgbClr val="F4F1EE"/>
-                </a:solidFill>
-                <a:latin typeface="Arial"/>
-              </a:rPr>
-              <a:t>Suppeq </a:t>
-            </a:r>
-            <a:r>
-              <a:rPr sz="945" b="0">
-                <a:solidFill>
-                  <a:srgbClr val="F4F1EE"/>
-                </a:solidFill>
-                <a:latin typeface="Arial"/>
-              </a:rPr>
-              <a:t>· </a:t>
-            </a:r>
-            <a:r>
-              <a:rPr sz="945" b="0">
-                <a:solidFill>
-                  <a:srgbClr val="F4F1EE"/>
-                </a:solidFill>
-                <a:latin typeface="Arial"/>
-              </a:rPr>
-              <a:t>Truck </a:t>
-            </a:r>
-            <a:r>
-              <a:rPr sz="945" b="0">
-                <a:solidFill>
-                  <a:srgbClr val="F4F1EE"/>
-                </a:solidFill>
-                <a:latin typeface="Arial"/>
-              </a:rPr>
-              <a:t>Others</a:t>
-            </a:r>
-          </a:p>
-        </p:txBody>
-      </p:sp>
-      <p:sp>
-        <p:nvSpPr>
-          <p:cNvPr id="14" name="TextBox 13"/>
-          <p:cNvSpPr txBox="1"/>
-          <p:nvPr/>
-        </p:nvSpPr>
-        <p:spPr>
-          <a:xfrm>
-            <a:off x="561975" y="3258693"/>
-            <a:ext cx="1202680" cy="104775"/>
-          </a:xfrm>
-          <a:prstGeom prst="rect">
-            <a:avLst/>
-          </a:prstGeom>
-          <a:noFill/>
-        </p:spPr>
-        <p:txBody>
-          <a:bodyPr wrap="none" lIns="0" rIns="0" tIns="0" bIns="0" anchor="t">
-            <a:spAutoFit/>
-          </a:bodyPr>
-          <a:lstStyle/>
-          <a:p>
-            <a:pPr algn="l"/>
-            <a:r>
-              <a:rPr sz="691" b="0">
-                <a:solidFill>
-                  <a:srgbClr val="6F6963"/>
-                </a:solidFill>
-                <a:latin typeface="Arial"/>
-              </a:rPr>
-              <a:t>DATE </a:t>
-            </a:r>
-            <a:r>
-              <a:rPr sz="691" b="0">
-                <a:solidFill>
-                  <a:srgbClr val="6F6963"/>
-                </a:solidFill>
-                <a:latin typeface="Arial"/>
-              </a:rPr>
-              <a:t>OF </a:t>
-            </a:r>
-            <a:r>
-              <a:rPr sz="691" b="0">
-                <a:solidFill>
-                  <a:srgbClr val="6F6963"/>
-                </a:solidFill>
-                <a:latin typeface="Arial"/>
-              </a:rPr>
-              <a:t>BIRTH</a:t>
-            </a:r>
-          </a:p>
-        </p:txBody>
-      </p:sp>
-      <p:sp>
-        <p:nvSpPr>
-          <p:cNvPr id="15" name="TextBox 14"/>
-          <p:cNvSpPr txBox="1"/>
-          <p:nvPr/>
-        </p:nvSpPr>
-        <p:spPr>
-          <a:xfrm>
-            <a:off x="561975" y="3360420"/>
-            <a:ext cx="766464" cy="142875"/>
-          </a:xfrm>
-          <a:prstGeom prst="rect">
-            <a:avLst/>
-          </a:prstGeom>
-          <a:noFill/>
-        </p:spPr>
-        <p:txBody>
-          <a:bodyPr wrap="none" lIns="0" rIns="0" tIns="0" bIns="0" anchor="t">
-            <a:spAutoFit/>
-          </a:bodyPr>
-          <a:lstStyle/>
-          <a:p>
-            <a:pPr algn="l"/>
-            <a:r>
-              <a:rPr sz="945" b="0">
-                <a:solidFill>
-                  <a:srgbClr val="F4F1EE"/>
-                </a:solidFill>
-                <a:latin typeface="Arial"/>
-              </a:rPr>
-              <a:t>[ </a:t>
-            </a:r>
-            <a:r>
-              <a:rPr sz="945" b="0">
-                <a:solidFill>
-                  <a:srgbClr val="F4F1EE"/>
-                </a:solidFill>
-                <a:latin typeface="Arial"/>
-              </a:rPr>
-              <a:t>fill </a:t>
-            </a:r>
-            <a:r>
-              <a:rPr sz="945" b="0">
-                <a:solidFill>
-                  <a:srgbClr val="F4F1EE"/>
-                </a:solidFill>
-                <a:latin typeface="Arial"/>
-              </a:rPr>
-              <a:t>in </a:t>
-            </a:r>
-            <a:r>
-              <a:rPr sz="945" b="0">
-                <a:solidFill>
-                  <a:srgbClr val="F4F1EE"/>
-                </a:solidFill>
-                <a:latin typeface="Arial"/>
-              </a:rPr>
-              <a:t>]</a:t>
-            </a:r>
-          </a:p>
-        </p:txBody>
-      </p:sp>
-      <p:sp>
-        <p:nvSpPr>
-          <p:cNvPr id="16" name="TextBox 15"/>
-          <p:cNvSpPr txBox="1"/>
-          <p:nvPr/>
-        </p:nvSpPr>
-        <p:spPr>
-          <a:xfrm>
-            <a:off x="561975" y="3630168"/>
-            <a:ext cx="1275605" cy="104775"/>
-          </a:xfrm>
-          <a:prstGeom prst="rect">
-            <a:avLst/>
-          </a:prstGeom>
-          <a:noFill/>
-        </p:spPr>
-        <p:txBody>
-          <a:bodyPr wrap="none" lIns="0" rIns="0" tIns="0" bIns="0" anchor="t">
-            <a:spAutoFit/>
-          </a:bodyPr>
-          <a:lstStyle/>
-          <a:p>
-            <a:pPr algn="l"/>
-            <a:r>
-              <a:rPr sz="691" b="0">
-                <a:solidFill>
-                  <a:srgbClr val="6F6963"/>
-                </a:solidFill>
-                <a:latin typeface="Arial"/>
-              </a:rPr>
-              <a:t>PLACE </a:t>
-            </a:r>
-            <a:r>
-              <a:rPr sz="691" b="0">
-                <a:solidFill>
-                  <a:srgbClr val="6F6963"/>
-                </a:solidFill>
-                <a:latin typeface="Arial"/>
-              </a:rPr>
-              <a:t>OF </a:t>
-            </a:r>
-            <a:r>
-              <a:rPr sz="691" b="0">
-                <a:solidFill>
-                  <a:srgbClr val="6F6963"/>
-                </a:solidFill>
-                <a:latin typeface="Arial"/>
-              </a:rPr>
-              <a:t>BIRTH</a:t>
-            </a:r>
-          </a:p>
-        </p:txBody>
-      </p:sp>
-      <p:sp>
-        <p:nvSpPr>
-          <p:cNvPr id="17" name="TextBox 16"/>
-          <p:cNvSpPr txBox="1"/>
-          <p:nvPr/>
-        </p:nvSpPr>
-        <p:spPr>
-          <a:xfrm>
-            <a:off x="561975" y="3731895"/>
-            <a:ext cx="766464" cy="142875"/>
-          </a:xfrm>
-          <a:prstGeom prst="rect">
-            <a:avLst/>
-          </a:prstGeom>
-          <a:noFill/>
-        </p:spPr>
-        <p:txBody>
-          <a:bodyPr wrap="none" lIns="0" rIns="0" tIns="0" bIns="0" anchor="t">
-            <a:spAutoFit/>
-          </a:bodyPr>
-          <a:lstStyle/>
-          <a:p>
-            <a:pPr algn="l"/>
-            <a:r>
-              <a:rPr sz="945" b="0">
-                <a:solidFill>
-                  <a:srgbClr val="F4F1EE"/>
-                </a:solidFill>
-                <a:latin typeface="Arial"/>
-              </a:rPr>
-              <a:t>[ </a:t>
-            </a:r>
-            <a:r>
-              <a:rPr sz="945" b="0">
-                <a:solidFill>
-                  <a:srgbClr val="F4F1EE"/>
-                </a:solidFill>
-                <a:latin typeface="Arial"/>
-              </a:rPr>
-              <a:t>fill </a:t>
-            </a:r>
-            <a:r>
-              <a:rPr sz="945" b="0">
-                <a:solidFill>
-                  <a:srgbClr val="F4F1EE"/>
-                </a:solidFill>
-                <a:latin typeface="Arial"/>
-              </a:rPr>
-              <a:t>in </a:t>
-            </a:r>
-            <a:r>
-              <a:rPr sz="945" b="0">
-                <a:solidFill>
-                  <a:srgbClr val="F4F1EE"/>
-                </a:solidFill>
-                <a:latin typeface="Arial"/>
-              </a:rPr>
-              <a:t>]</a:t>
-            </a:r>
-          </a:p>
-        </p:txBody>
-      </p:sp>
-      <p:sp>
-        <p:nvSpPr>
-          <p:cNvPr id="18" name="TextBox 17"/>
-          <p:cNvSpPr txBox="1"/>
-          <p:nvPr/>
-        </p:nvSpPr>
-        <p:spPr>
-          <a:xfrm>
-            <a:off x="561975" y="4001643"/>
-            <a:ext cx="706933" cy="104775"/>
-          </a:xfrm>
-          <a:prstGeom prst="rect">
-            <a:avLst/>
-          </a:prstGeom>
-          <a:noFill/>
-        </p:spPr>
-        <p:txBody>
-          <a:bodyPr wrap="none" lIns="0" rIns="0" tIns="0" bIns="0" anchor="t">
-            <a:spAutoFit/>
-          </a:bodyPr>
-          <a:lstStyle/>
-          <a:p>
-            <a:pPr algn="l"/>
-            <a:r>
-              <a:rPr sz="691" b="0">
-                <a:solidFill>
-                  <a:srgbClr val="6F6963"/>
-                </a:solidFill>
-                <a:latin typeface="Arial"/>
-              </a:rPr>
-              <a:t>EMAIL</a:t>
-            </a:r>
-          </a:p>
-        </p:txBody>
-      </p:sp>
-      <p:sp>
-        <p:nvSpPr>
-          <p:cNvPr id="19" name="TextBox 18"/>
-          <p:cNvSpPr txBox="1"/>
-          <p:nvPr/>
-        </p:nvSpPr>
-        <p:spPr>
-          <a:xfrm>
-            <a:off x="561975" y="4103370"/>
-            <a:ext cx="1504503" cy="142875"/>
-          </a:xfrm>
-          <a:prstGeom prst="rect">
-            <a:avLst/>
-          </a:prstGeom>
-          <a:noFill/>
-        </p:spPr>
-        <p:txBody>
-          <a:bodyPr wrap="none" lIns="0" rIns="0" tIns="0" bIns="0" anchor="t">
-            <a:spAutoFit/>
-          </a:bodyPr>
-          <a:lstStyle/>
-          <a:p>
-            <a:pPr algn="l"/>
-            <a:r>
-              <a:rPr sz="945" b="0">
-                <a:solidFill>
-                  <a:srgbClr val="F4F1EE"/>
-                </a:solidFill>
-                <a:latin typeface="Arial"/>
-              </a:rPr>
-              <a:t>[ </a:t>
-            </a:r>
-            <a:r>
-              <a:rPr sz="945" b="0">
-                <a:solidFill>
-                  <a:srgbClr val="F4F1EE"/>
-                </a:solidFill>
-                <a:latin typeface="Arial"/>
-              </a:rPr>
-              <a:t>fill </a:t>
-            </a:r>
-            <a:r>
-              <a:rPr sz="945" b="0">
-                <a:solidFill>
-                  <a:srgbClr val="F4F1EE"/>
-                </a:solidFill>
-                <a:latin typeface="Arial"/>
-              </a:rPr>
-              <a:t>in </a:t>
-            </a:r>
-            <a:r>
-              <a:rPr sz="945" b="0">
-                <a:solidFill>
-                  <a:srgbClr val="F4F1EE"/>
-                </a:solidFill>
-                <a:latin typeface="Arial"/>
-              </a:rPr>
-              <a:t>]@triatra.co.id</a:t>
-            </a:r>
-          </a:p>
-        </p:txBody>
-      </p:sp>
-      <p:sp>
-        <p:nvSpPr>
-          <p:cNvPr id="20" name="TextBox 19"/>
-          <p:cNvSpPr txBox="1"/>
-          <p:nvPr/>
-        </p:nvSpPr>
-        <p:spPr>
-          <a:xfrm>
-            <a:off x="561975" y="4373118"/>
-            <a:ext cx="885229" cy="104775"/>
-          </a:xfrm>
-          <a:prstGeom prst="rect">
-            <a:avLst/>
-          </a:prstGeom>
-          <a:noFill/>
-        </p:spPr>
-        <p:txBody>
-          <a:bodyPr wrap="none" lIns="0" rIns="0" tIns="0" bIns="0" anchor="t">
-            <a:spAutoFit/>
-          </a:bodyPr>
-          <a:lstStyle/>
-          <a:p>
-            <a:pPr algn="l"/>
-            <a:r>
-              <a:rPr sz="691" b="0">
-                <a:solidFill>
-                  <a:srgbClr val="6F6963"/>
-                </a:solidFill>
-                <a:latin typeface="Arial"/>
-              </a:rPr>
-              <a:t>LINKEDIN</a:t>
-            </a:r>
-          </a:p>
-        </p:txBody>
-      </p:sp>
-      <p:sp>
-        <p:nvSpPr>
-          <p:cNvPr id="21" name="TextBox 20"/>
-          <p:cNvSpPr txBox="1"/>
-          <p:nvPr/>
-        </p:nvSpPr>
-        <p:spPr>
-          <a:xfrm>
-            <a:off x="561975" y="4474845"/>
-            <a:ext cx="766464" cy="142875"/>
-          </a:xfrm>
-          <a:prstGeom prst="rect">
-            <a:avLst/>
-          </a:prstGeom>
-          <a:noFill/>
-        </p:spPr>
-        <p:txBody>
-          <a:bodyPr wrap="none" lIns="0" rIns="0" tIns="0" bIns="0" anchor="t">
-            <a:spAutoFit/>
-          </a:bodyPr>
-          <a:lstStyle/>
-          <a:p>
-            <a:pPr algn="l"/>
-            <a:r>
-              <a:rPr sz="945" b="0">
-                <a:solidFill>
-                  <a:srgbClr val="F4F1EE"/>
-                </a:solidFill>
-                <a:latin typeface="Arial"/>
-              </a:rPr>
-              <a:t>[ </a:t>
-            </a:r>
-            <a:r>
-              <a:rPr sz="945" b="0">
-                <a:solidFill>
-                  <a:srgbClr val="F4F1EE"/>
-                </a:solidFill>
-                <a:latin typeface="Arial"/>
-              </a:rPr>
-              <a:t>fill </a:t>
-            </a:r>
-            <a:r>
-              <a:rPr sz="945" b="0">
-                <a:solidFill>
-                  <a:srgbClr val="F4F1EE"/>
-                </a:solidFill>
-                <a:latin typeface="Arial"/>
-              </a:rPr>
-              <a:t>in </a:t>
-            </a:r>
-            <a:r>
-              <a:rPr sz="945" b="0">
-                <a:solidFill>
-                  <a:srgbClr val="F4F1EE"/>
-                </a:solidFill>
-                <a:latin typeface="Arial"/>
-              </a:rPr>
-              <a:t>]</a:t>
-            </a:r>
-          </a:p>
-        </p:txBody>
-      </p:sp>
-      <p:sp>
-        <p:nvSpPr>
-          <p:cNvPr id="22" name="TextBox 21"/>
-          <p:cNvSpPr txBox="1"/>
-          <p:nvPr/>
-        </p:nvSpPr>
-        <p:spPr>
-          <a:xfrm>
-            <a:off x="4201120" y="1522857"/>
-            <a:ext cx="956518" cy="133350"/>
+              <a:rPr sz="873" b="0">
+                <a:solidFill>
+                  <a:srgbClr val="A9A29C"/>
+                </a:solidFill>
+                <a:latin typeface="Arial"/>
+              </a:rPr>
+              <a:t>Coordinator</a:t>
+            </a:r>
+          </a:p>
+        </p:txBody>
+      </p:sp>
+      <p:sp>
+        <p:nvSpPr>
+          <p:cNvPr id="31" name="TextBox 30"/>
+          <p:cNvSpPr txBox="1"/>
+          <p:nvPr/>
+        </p:nvSpPr>
+        <p:spPr>
+          <a:xfrm>
+            <a:off x="7666732" y="4873275"/>
+            <a:ext cx="1016644" cy="133350"/>
+          </a:xfrm>
+          <a:prstGeom prst="rect">
+            <a:avLst/>
+          </a:prstGeom>
+          <a:noFill/>
+        </p:spPr>
+        <p:txBody>
+          <a:bodyPr wrap="none" lIns="0" rIns="0" tIns="0" bIns="0" anchor="t">
+            <a:spAutoFit/>
+          </a:bodyPr>
+          <a:lstStyle/>
+          <a:p>
+            <a:pPr algn="l"/>
+            <a:r>
+              <a:rPr sz="873" b="1">
+                <a:solidFill>
+                  <a:srgbClr val="FF5A1F"/>
+                </a:solidFill>
+                <a:latin typeface="Arial"/>
+              </a:rPr>
+              <a:t>2021 </a:t>
+            </a:r>
+            <a:r>
+              <a:rPr sz="873" b="1">
+                <a:solidFill>
+                  <a:srgbClr val="FF5A1F"/>
+                </a:solidFill>
+                <a:latin typeface="Arial"/>
+              </a:rPr>
+              <a:t>– </a:t>
+            </a:r>
+            <a:r>
+              <a:rPr sz="873" b="1">
+                <a:solidFill>
+                  <a:srgbClr val="FF5A1F"/>
+                </a:solidFill>
+                <a:latin typeface="Arial"/>
+              </a:rPr>
+              <a:t>2023</a:t>
+            </a:r>
+          </a:p>
+        </p:txBody>
+      </p:sp>
+      <p:sp>
+        <p:nvSpPr>
+          <p:cNvPr id="32" name="TextBox 31"/>
+          <p:cNvSpPr txBox="1"/>
+          <p:nvPr/>
+        </p:nvSpPr>
+        <p:spPr>
+          <a:xfrm>
+            <a:off x="3948261" y="5618607"/>
+            <a:ext cx="1108769" cy="133350"/>
           </a:xfrm>
           <a:prstGeom prst="rect">
             <a:avLst/>
@@ -52450,21 +52935,21 @@
                 </a:solidFill>
                 <a:latin typeface="Arial"/>
               </a:rPr>
-              <a:t>Education</a:t>
-            </a:r>
-          </a:p>
-        </p:txBody>
-      </p:sp>
-      <p:sp>
-        <p:nvSpPr>
-          <p:cNvPr id="23" name="TextBox 22"/>
-          <p:cNvSpPr txBox="1"/>
-          <p:nvPr/>
-        </p:nvSpPr>
-        <p:spPr>
-          <a:xfrm>
-            <a:off x="4315420" y="1768983"/>
-            <a:ext cx="1188839" cy="152400"/>
+              <a:t>Organization</a:t>
+            </a:r>
+          </a:p>
+        </p:txBody>
+      </p:sp>
+      <p:sp>
+        <p:nvSpPr>
+          <p:cNvPr id="33" name="TextBox 32"/>
+          <p:cNvSpPr txBox="1"/>
+          <p:nvPr/>
+        </p:nvSpPr>
+        <p:spPr>
+          <a:xfrm>
+            <a:off x="4767411" y="5931408"/>
+            <a:ext cx="2537668" cy="152400"/>
           </a:xfrm>
           <a:prstGeom prst="rect">
             <a:avLst/>
@@ -52485,7 +52970,7 @@
                 </a:solidFill>
                 <a:latin typeface="Arial"/>
               </a:rPr>
-              <a:t>[ </a:t>
+              <a:t>HMJM </a:t>
             </a:r>
             <a:r>
               <a:rPr sz="1018" b="1">
@@ -52494,7 +52979,7 @@
                 </a:solidFill>
                 <a:latin typeface="Arial"/>
               </a:rPr>
-              <a:t>University </a:t>
+              <a:t>Universitas </a:t>
             </a:r>
             <a:r>
               <a:rPr sz="1018" b="1">
@@ -52503,21 +52988,30 @@
                 </a:solidFill>
                 <a:latin typeface="Arial"/>
               </a:rPr>
-              <a:t>]</a:t>
-            </a:r>
-          </a:p>
-        </p:txBody>
-      </p:sp>
-      <p:sp>
-        <p:nvSpPr>
-          <p:cNvPr id="24" name="TextBox 23"/>
-          <p:cNvSpPr txBox="1"/>
-          <p:nvPr/>
-        </p:nvSpPr>
-        <p:spPr>
-          <a:xfrm>
-            <a:off x="4315420" y="1922907"/>
-            <a:ext cx="1270396" cy="133350"/>
+              <a:t>Sanata </a:t>
+            </a:r>
+            <a:r>
+              <a:rPr sz="1018" b="1">
+                <a:solidFill>
+                  <a:srgbClr val="F4F1EE"/>
+                </a:solidFill>
+                <a:latin typeface="Arial"/>
+              </a:rPr>
+              <a:t>Dharma</a:t>
+            </a:r>
+          </a:p>
+        </p:txBody>
+      </p:sp>
+      <p:sp>
+        <p:nvSpPr>
+          <p:cNvPr id="34" name="TextBox 33"/>
+          <p:cNvSpPr txBox="1"/>
+          <p:nvPr/>
+        </p:nvSpPr>
+        <p:spPr>
+          <a:xfrm>
+            <a:off x="4767411" y="6085332"/>
+            <a:ext cx="863947" cy="133350"/>
           </a:xfrm>
           <a:prstGeom prst="rect">
             <a:avLst/>
@@ -52538,680 +53032,67 @@
                 </a:solidFill>
                 <a:latin typeface="Arial"/>
               </a:rPr>
-              <a:t>[ </a:t>
-            </a:r>
-            <a:r>
-              <a:rPr sz="873" b="0">
-                <a:solidFill>
-                  <a:srgbClr val="A9A29C"/>
-                </a:solidFill>
-                <a:latin typeface="Arial"/>
-              </a:rPr>
-              <a:t>Degree </a:t>
-            </a:r>
-            <a:r>
-              <a:rPr sz="873" b="0">
-                <a:solidFill>
-                  <a:srgbClr val="A9A29C"/>
-                </a:solidFill>
-                <a:latin typeface="Arial"/>
-              </a:rPr>
-              <a:t>· </a:t>
-            </a:r>
-            <a:r>
-              <a:rPr sz="873" b="0">
-                <a:solidFill>
-                  <a:srgbClr val="A9A29C"/>
-                </a:solidFill>
-                <a:latin typeface="Arial"/>
-              </a:rPr>
-              <a:t>Major </a:t>
-            </a:r>
-            <a:r>
-              <a:rPr sz="873" b="0">
-                <a:solidFill>
-                  <a:srgbClr val="A9A29C"/>
-                </a:solidFill>
-                <a:latin typeface="Arial"/>
-              </a:rPr>
-              <a:t>]</a:t>
-            </a:r>
-          </a:p>
-        </p:txBody>
-      </p:sp>
-      <p:sp>
-        <p:nvSpPr>
-          <p:cNvPr id="25" name="TextBox 24"/>
-          <p:cNvSpPr txBox="1"/>
-          <p:nvPr/>
-        </p:nvSpPr>
-        <p:spPr>
-          <a:xfrm>
-            <a:off x="4315420" y="2056257"/>
-            <a:ext cx="2100857" cy="133350"/>
-          </a:xfrm>
-          <a:prstGeom prst="rect">
-            <a:avLst/>
-          </a:prstGeom>
-          <a:noFill/>
-        </p:spPr>
-        <p:txBody>
-          <a:bodyPr wrap="none" lIns="0" rIns="0" tIns="0" bIns="0" anchor="t">
-            <a:spAutoFit/>
-          </a:bodyPr>
-          <a:lstStyle/>
-          <a:p>
-            <a:pPr algn="l"/>
-            <a:r>
-              <a:rPr sz="873" b="0">
-                <a:solidFill>
-                  <a:srgbClr val="A9A29C"/>
-                </a:solidFill>
-                <a:latin typeface="Arial"/>
-              </a:rPr>
-              <a:t>[ </a:t>
-            </a:r>
-            <a:r>
-              <a:rPr sz="873" b="0">
-                <a:solidFill>
-                  <a:srgbClr val="A9A29C"/>
-                </a:solidFill>
-                <a:latin typeface="Arial"/>
-              </a:rPr>
-              <a:t>Year </a:t>
-            </a:r>
-            <a:r>
-              <a:rPr sz="873" b="0">
-                <a:solidFill>
-                  <a:srgbClr val="A9A29C"/>
+              <a:t>President</a:t>
+            </a:r>
+          </a:p>
+        </p:txBody>
+      </p:sp>
+      <p:sp>
+        <p:nvSpPr>
+          <p:cNvPr id="35" name="TextBox 34"/>
+          <p:cNvSpPr txBox="1"/>
+          <p:nvPr/>
+        </p:nvSpPr>
+        <p:spPr>
+          <a:xfrm>
+            <a:off x="7666732" y="6009132"/>
+            <a:ext cx="1016644" cy="133350"/>
+          </a:xfrm>
+          <a:prstGeom prst="rect">
+            <a:avLst/>
+          </a:prstGeom>
+          <a:noFill/>
+        </p:spPr>
+        <p:txBody>
+          <a:bodyPr wrap="none" lIns="0" rIns="0" tIns="0" bIns="0" anchor="t">
+            <a:spAutoFit/>
+          </a:bodyPr>
+          <a:lstStyle/>
+          <a:p>
+            <a:pPr algn="l"/>
+            <a:r>
+              <a:rPr sz="873" b="1">
+                <a:solidFill>
+                  <a:srgbClr val="FF5A1F"/>
+                </a:solidFill>
+                <a:latin typeface="Arial"/>
+              </a:rPr>
+              <a:t>2021 </a:t>
+            </a:r>
+            <a:r>
+              <a:rPr sz="873" b="1">
+                <a:solidFill>
+                  <a:srgbClr val="FF5A1F"/>
                 </a:solidFill>
                 <a:latin typeface="Arial"/>
               </a:rPr>
               <a:t>– </a:t>
             </a:r>
             <a:r>
-              <a:rPr sz="873" b="0">
-                <a:solidFill>
-                  <a:srgbClr val="A9A29C"/>
-                </a:solidFill>
-                <a:latin typeface="Arial"/>
-              </a:rPr>
-              <a:t>Year </a:t>
-            </a:r>
-            <a:r>
-              <a:rPr sz="873" b="0">
-                <a:solidFill>
-                  <a:srgbClr val="A9A29C"/>
-                </a:solidFill>
-                <a:latin typeface="Arial"/>
-              </a:rPr>
-              <a:t>] </a:t>
-            </a:r>
-            <a:r>
-              <a:rPr sz="873" b="0">
-                <a:solidFill>
-                  <a:srgbClr val="A9A29C"/>
-                </a:solidFill>
-                <a:latin typeface="Arial"/>
-              </a:rPr>
-              <a:t>· </a:t>
-            </a:r>
-            <a:r>
-              <a:rPr sz="873" b="0">
-                <a:solidFill>
-                  <a:srgbClr val="A9A29C"/>
-                </a:solidFill>
-                <a:latin typeface="Arial"/>
-              </a:rPr>
-              <a:t>GPA </a:t>
-            </a:r>
-            <a:r>
-              <a:rPr sz="873" b="0">
-                <a:solidFill>
-                  <a:srgbClr val="A9A29C"/>
-                </a:solidFill>
-                <a:latin typeface="Arial"/>
-              </a:rPr>
-              <a:t>[ </a:t>
-            </a:r>
-            <a:r>
-              <a:rPr sz="873" b="0">
-                <a:solidFill>
-                  <a:srgbClr val="A9A29C"/>
-                </a:solidFill>
-                <a:latin typeface="Arial"/>
-              </a:rPr>
-              <a:t>x.xx </a:t>
-            </a:r>
-            <a:r>
-              <a:rPr sz="873" b="0">
-                <a:solidFill>
-                  <a:srgbClr val="A9A29C"/>
-                </a:solidFill>
-                <a:latin typeface="Arial"/>
-              </a:rPr>
-              <a:t>/ </a:t>
-            </a:r>
-            <a:r>
-              <a:rPr sz="873" b="0">
-                <a:solidFill>
-                  <a:srgbClr val="A9A29C"/>
-                </a:solidFill>
-                <a:latin typeface="Arial"/>
-              </a:rPr>
-              <a:t>4.00 </a:t>
-            </a:r>
-            <a:r>
-              <a:rPr sz="873" b="0">
-                <a:solidFill>
-                  <a:srgbClr val="A9A29C"/>
-                </a:solidFill>
-                <a:latin typeface="Arial"/>
-              </a:rPr>
-              <a:t>]</a:t>
-            </a:r>
-          </a:p>
-        </p:txBody>
-      </p:sp>
-      <p:sp>
-        <p:nvSpPr>
-          <p:cNvPr id="26" name="TextBox 25"/>
-          <p:cNvSpPr txBox="1"/>
-          <p:nvPr/>
-        </p:nvSpPr>
-        <p:spPr>
-          <a:xfrm>
-            <a:off x="4201120" y="2361057"/>
-            <a:ext cx="1344959" cy="133350"/>
-          </a:xfrm>
-          <a:prstGeom prst="rect">
-            <a:avLst/>
-          </a:prstGeom>
-          <a:noFill/>
-        </p:spPr>
-        <p:txBody>
-          <a:bodyPr wrap="none" lIns="0" rIns="0" tIns="0" bIns="0" anchor="t">
-            <a:spAutoFit/>
-          </a:bodyPr>
-          <a:lstStyle/>
-          <a:p>
-            <a:pPr algn="l"/>
-            <a:r>
-              <a:rPr sz="909" b="1">
-                <a:solidFill>
-                  <a:srgbClr val="F4F1EE"/>
-                </a:solidFill>
-                <a:latin typeface="Arial"/>
-              </a:rPr>
-              <a:t>Work </a:t>
-            </a:r>
-            <a:r>
-              <a:rPr sz="909" b="1">
-                <a:solidFill>
-                  <a:srgbClr val="F4F1EE"/>
-                </a:solidFill>
-                <a:latin typeface="Arial"/>
-              </a:rPr>
-              <a:t>Experience</a:t>
-            </a:r>
-          </a:p>
-        </p:txBody>
-      </p:sp>
-      <p:sp>
-        <p:nvSpPr>
-          <p:cNvPr id="27" name="TextBox 26"/>
-          <p:cNvSpPr txBox="1"/>
-          <p:nvPr/>
-        </p:nvSpPr>
-        <p:spPr>
-          <a:xfrm>
-            <a:off x="4315420" y="2607183"/>
-            <a:ext cx="2122735" cy="152400"/>
-          </a:xfrm>
-          <a:prstGeom prst="rect">
-            <a:avLst/>
-          </a:prstGeom>
-          <a:noFill/>
-        </p:spPr>
-        <p:txBody>
-          <a:bodyPr wrap="none" lIns="0" rIns="0" tIns="0" bIns="0" anchor="t">
-            <a:spAutoFit/>
-          </a:bodyPr>
-          <a:lstStyle/>
-          <a:p>
-            <a:pPr algn="l"/>
-            <a:r>
-              <a:rPr sz="1018" b="1">
-                <a:solidFill>
-                  <a:srgbClr val="F4F1EE"/>
-                </a:solidFill>
-                <a:latin typeface="Arial"/>
-              </a:rPr>
-              <a:t>PT </a:t>
-            </a:r>
-            <a:r>
-              <a:rPr sz="1018" b="1">
-                <a:solidFill>
-                  <a:srgbClr val="F4F1EE"/>
-                </a:solidFill>
-                <a:latin typeface="Arial"/>
-              </a:rPr>
-              <a:t>Triatra </a:t>
-            </a:r>
-            <a:r>
-              <a:rPr sz="1018" b="1">
-                <a:solidFill>
-                  <a:srgbClr val="F4F1EE"/>
-                </a:solidFill>
-                <a:latin typeface="Arial"/>
-              </a:rPr>
-              <a:t>Sinergia </a:t>
-            </a:r>
-            <a:r>
-              <a:rPr sz="1018" b="1">
-                <a:solidFill>
-                  <a:srgbClr val="F4F1EE"/>
-                </a:solidFill>
-                <a:latin typeface="Arial"/>
-              </a:rPr>
-              <a:t>Pratama</a:t>
-            </a:r>
-          </a:p>
-        </p:txBody>
-      </p:sp>
-      <p:sp>
-        <p:nvSpPr>
-          <p:cNvPr id="28" name="TextBox 27"/>
-          <p:cNvSpPr txBox="1"/>
-          <p:nvPr/>
-        </p:nvSpPr>
-        <p:spPr>
-          <a:xfrm>
-            <a:off x="4315420" y="2761107"/>
-            <a:ext cx="2674590" cy="133350"/>
-          </a:xfrm>
-          <a:prstGeom prst="rect">
-            <a:avLst/>
-          </a:prstGeom>
-          <a:noFill/>
-        </p:spPr>
-        <p:txBody>
-          <a:bodyPr wrap="none" lIns="0" rIns="0" tIns="0" bIns="0" anchor="t">
-            <a:spAutoFit/>
-          </a:bodyPr>
-          <a:lstStyle/>
-          <a:p>
-            <a:pPr algn="l"/>
-            <a:r>
-              <a:rPr sz="873" b="0">
-                <a:solidFill>
-                  <a:srgbClr val="A9A29C"/>
-                </a:solidFill>
-                <a:latin typeface="Arial"/>
-              </a:rPr>
-              <a:t>Marketing </a:t>
-            </a:r>
-            <a:r>
-              <a:rPr sz="873" b="0">
-                <a:solidFill>
-                  <a:srgbClr val="A9A29C"/>
-                </a:solidFill>
-                <a:latin typeface="Arial"/>
-              </a:rPr>
-              <a:t>Strategic </a:t>
-            </a:r>
-            <a:r>
-              <a:rPr sz="873" b="0">
-                <a:solidFill>
-                  <a:srgbClr val="A9A29C"/>
-                </a:solidFill>
-                <a:latin typeface="Arial"/>
-              </a:rPr>
-              <a:t>2 </a:t>
-            </a:r>
-            <a:r>
-              <a:rPr sz="873" b="0">
-                <a:solidFill>
-                  <a:srgbClr val="A9A29C"/>
-                </a:solidFill>
-                <a:latin typeface="Arial"/>
-              </a:rPr>
-              <a:t>Associate </a:t>
-            </a:r>
-            <a:r>
-              <a:rPr sz="873" b="0">
-                <a:solidFill>
-                  <a:srgbClr val="A9A29C"/>
-                </a:solidFill>
-                <a:latin typeface="Arial"/>
-              </a:rPr>
-              <a:t>· </a:t>
-            </a:r>
-            <a:r>
-              <a:rPr sz="873" b="0">
-                <a:solidFill>
-                  <a:srgbClr val="A9A29C"/>
-                </a:solidFill>
-                <a:latin typeface="Arial"/>
-              </a:rPr>
-              <a:t>2026 </a:t>
-            </a:r>
-            <a:r>
-              <a:rPr sz="873" b="0">
-                <a:solidFill>
-                  <a:srgbClr val="A9A29C"/>
-                </a:solidFill>
-                <a:latin typeface="Arial"/>
-              </a:rPr>
-              <a:t>– </a:t>
-            </a:r>
-            <a:r>
-              <a:rPr sz="873" b="0">
-                <a:solidFill>
-                  <a:srgbClr val="A9A29C"/>
-                </a:solidFill>
-                <a:latin typeface="Arial"/>
-              </a:rPr>
-              <a:t>now</a:t>
-            </a:r>
-          </a:p>
-        </p:txBody>
-      </p:sp>
-      <p:sp>
-        <p:nvSpPr>
-          <p:cNvPr id="29" name="TextBox 28"/>
-          <p:cNvSpPr txBox="1"/>
-          <p:nvPr/>
-        </p:nvSpPr>
-        <p:spPr>
-          <a:xfrm>
-            <a:off x="4315420" y="3045333"/>
-            <a:ext cx="1151483" cy="152400"/>
-          </a:xfrm>
-          <a:prstGeom prst="rect">
-            <a:avLst/>
-          </a:prstGeom>
-          <a:noFill/>
-        </p:spPr>
-        <p:txBody>
-          <a:bodyPr wrap="none" lIns="0" rIns="0" tIns="0" bIns="0" anchor="t">
-            <a:spAutoFit/>
-          </a:bodyPr>
-          <a:lstStyle/>
-          <a:p>
-            <a:pPr algn="l"/>
-            <a:r>
-              <a:rPr sz="1018" b="1">
-                <a:solidFill>
-                  <a:srgbClr val="F4F1EE"/>
-                </a:solidFill>
-                <a:latin typeface="Arial"/>
-              </a:rPr>
-              <a:t>[ </a:t>
-            </a:r>
-            <a:r>
-              <a:rPr sz="1018" b="1">
-                <a:solidFill>
-                  <a:srgbClr val="F4F1EE"/>
-                </a:solidFill>
-                <a:latin typeface="Arial"/>
-              </a:rPr>
-              <a:t>Company </a:t>
-            </a:r>
-            <a:r>
-              <a:rPr sz="1018" b="1">
-                <a:solidFill>
-                  <a:srgbClr val="F4F1EE"/>
-                </a:solidFill>
-                <a:latin typeface="Arial"/>
-              </a:rPr>
-              <a:t>]</a:t>
-            </a:r>
-          </a:p>
-        </p:txBody>
-      </p:sp>
-      <p:sp>
-        <p:nvSpPr>
-          <p:cNvPr id="30" name="TextBox 29"/>
-          <p:cNvSpPr txBox="1"/>
-          <p:nvPr/>
-        </p:nvSpPr>
-        <p:spPr>
-          <a:xfrm>
-            <a:off x="4315420" y="3199257"/>
-            <a:ext cx="1175146" cy="133350"/>
-          </a:xfrm>
-          <a:prstGeom prst="rect">
-            <a:avLst/>
-          </a:prstGeom>
-          <a:noFill/>
-        </p:spPr>
-        <p:txBody>
-          <a:bodyPr wrap="none" lIns="0" rIns="0" tIns="0" bIns="0" anchor="t">
-            <a:spAutoFit/>
-          </a:bodyPr>
-          <a:lstStyle/>
-          <a:p>
-            <a:pPr algn="l"/>
-            <a:r>
-              <a:rPr sz="873" b="0">
-                <a:solidFill>
-                  <a:srgbClr val="A9A29C"/>
-                </a:solidFill>
-                <a:latin typeface="Arial"/>
-              </a:rPr>
-              <a:t>[ </a:t>
-            </a:r>
-            <a:r>
-              <a:rPr sz="873" b="0">
-                <a:solidFill>
-                  <a:srgbClr val="A9A29C"/>
-                </a:solidFill>
-                <a:latin typeface="Arial"/>
-              </a:rPr>
-              <a:t>Role </a:t>
-            </a:r>
-            <a:r>
-              <a:rPr sz="873" b="0">
-                <a:solidFill>
-                  <a:srgbClr val="A9A29C"/>
-                </a:solidFill>
-                <a:latin typeface="Arial"/>
-              </a:rPr>
-              <a:t>· </a:t>
-            </a:r>
-            <a:r>
-              <a:rPr sz="873" b="0">
-                <a:solidFill>
-                  <a:srgbClr val="A9A29C"/>
-                </a:solidFill>
-                <a:latin typeface="Arial"/>
-              </a:rPr>
-              <a:t>Period </a:t>
-            </a:r>
-            <a:r>
-              <a:rPr sz="873" b="0">
-                <a:solidFill>
-                  <a:srgbClr val="A9A29C"/>
-                </a:solidFill>
-                <a:latin typeface="Arial"/>
-              </a:rPr>
-              <a:t>]</a:t>
-            </a:r>
-          </a:p>
-        </p:txBody>
-      </p:sp>
-      <p:sp>
-        <p:nvSpPr>
-          <p:cNvPr id="31" name="TextBox 30"/>
-          <p:cNvSpPr txBox="1"/>
-          <p:nvPr/>
-        </p:nvSpPr>
-        <p:spPr>
-          <a:xfrm>
-            <a:off x="4315420" y="3483483"/>
-            <a:ext cx="1151483" cy="152400"/>
-          </a:xfrm>
-          <a:prstGeom prst="rect">
-            <a:avLst/>
-          </a:prstGeom>
-          <a:noFill/>
-        </p:spPr>
-        <p:txBody>
-          <a:bodyPr wrap="none" lIns="0" rIns="0" tIns="0" bIns="0" anchor="t">
-            <a:spAutoFit/>
-          </a:bodyPr>
-          <a:lstStyle/>
-          <a:p>
-            <a:pPr algn="l"/>
-            <a:r>
-              <a:rPr sz="1018" b="1">
-                <a:solidFill>
-                  <a:srgbClr val="F4F1EE"/>
-                </a:solidFill>
-                <a:latin typeface="Arial"/>
-              </a:rPr>
-              <a:t>[ </a:t>
-            </a:r>
-            <a:r>
-              <a:rPr sz="1018" b="1">
-                <a:solidFill>
-                  <a:srgbClr val="F4F1EE"/>
-                </a:solidFill>
-                <a:latin typeface="Arial"/>
-              </a:rPr>
-              <a:t>Company </a:t>
-            </a:r>
-            <a:r>
-              <a:rPr sz="1018" b="1">
-                <a:solidFill>
-                  <a:srgbClr val="F4F1EE"/>
-                </a:solidFill>
-                <a:latin typeface="Arial"/>
-              </a:rPr>
-              <a:t>]</a:t>
-            </a:r>
-          </a:p>
-        </p:txBody>
-      </p:sp>
-      <p:sp>
-        <p:nvSpPr>
-          <p:cNvPr id="32" name="TextBox 31"/>
-          <p:cNvSpPr txBox="1"/>
-          <p:nvPr/>
-        </p:nvSpPr>
-        <p:spPr>
-          <a:xfrm>
-            <a:off x="4315420" y="3637407"/>
-            <a:ext cx="1175146" cy="133350"/>
-          </a:xfrm>
-          <a:prstGeom prst="rect">
-            <a:avLst/>
-          </a:prstGeom>
-          <a:noFill/>
-        </p:spPr>
-        <p:txBody>
-          <a:bodyPr wrap="none" lIns="0" rIns="0" tIns="0" bIns="0" anchor="t">
-            <a:spAutoFit/>
-          </a:bodyPr>
-          <a:lstStyle/>
-          <a:p>
-            <a:pPr algn="l"/>
-            <a:r>
-              <a:rPr sz="873" b="0">
-                <a:solidFill>
-                  <a:srgbClr val="A9A29C"/>
-                </a:solidFill>
-                <a:latin typeface="Arial"/>
-              </a:rPr>
-              <a:t>[ </a:t>
-            </a:r>
-            <a:r>
-              <a:rPr sz="873" b="0">
-                <a:solidFill>
-                  <a:srgbClr val="A9A29C"/>
-                </a:solidFill>
-                <a:latin typeface="Arial"/>
-              </a:rPr>
-              <a:t>Role </a:t>
-            </a:r>
-            <a:r>
-              <a:rPr sz="873" b="0">
-                <a:solidFill>
-                  <a:srgbClr val="A9A29C"/>
-                </a:solidFill>
-                <a:latin typeface="Arial"/>
-              </a:rPr>
-              <a:t>· </a:t>
-            </a:r>
-            <a:r>
-              <a:rPr sz="873" b="0">
-                <a:solidFill>
-                  <a:srgbClr val="A9A29C"/>
-                </a:solidFill>
-                <a:latin typeface="Arial"/>
-              </a:rPr>
-              <a:t>Period </a:t>
-            </a:r>
-            <a:r>
-              <a:rPr sz="873" b="0">
-                <a:solidFill>
-                  <a:srgbClr val="A9A29C"/>
-                </a:solidFill>
-                <a:latin typeface="Arial"/>
-              </a:rPr>
-              <a:t>]</a:t>
-            </a:r>
-          </a:p>
-        </p:txBody>
-      </p:sp>
-      <p:sp>
-        <p:nvSpPr>
-          <p:cNvPr id="33" name="TextBox 32"/>
-          <p:cNvSpPr txBox="1"/>
-          <p:nvPr/>
-        </p:nvSpPr>
-        <p:spPr>
-          <a:xfrm>
-            <a:off x="9617719" y="3877056"/>
-            <a:ext cx="1501526" cy="114300"/>
-          </a:xfrm>
-          <a:prstGeom prst="rect">
-            <a:avLst/>
-          </a:prstGeom>
-          <a:noFill/>
-        </p:spPr>
-        <p:txBody>
-          <a:bodyPr wrap="none" lIns="0" rIns="0" tIns="0" bIns="0" anchor="t">
-            <a:spAutoFit/>
-          </a:bodyPr>
-          <a:lstStyle/>
-          <a:p>
-            <a:pPr algn="l"/>
-            <a:r>
-              <a:rPr sz="800" b="0">
-                <a:solidFill>
-                  <a:srgbClr val="6F6963"/>
-                </a:solidFill>
-                <a:latin typeface="Arial"/>
-              </a:rPr>
-              <a:t>PROFILE </a:t>
-            </a:r>
-            <a:r>
-              <a:rPr sz="800" b="0">
-                <a:solidFill>
-                  <a:srgbClr val="6F6963"/>
-                </a:solidFill>
-                <a:latin typeface="Arial"/>
-              </a:rPr>
-              <a:t>PHOTO</a:t>
-            </a:r>
-          </a:p>
-        </p:txBody>
-      </p:sp>
-      <p:sp>
-        <p:nvSpPr>
-          <p:cNvPr id="34" name="TextBox 33"/>
+              <a:rPr sz="873" b="1">
+                <a:solidFill>
+                  <a:srgbClr val="FF5A1F"/>
+                </a:solidFill>
+                <a:latin typeface="Arial"/>
+              </a:rPr>
+              <a:t>2022</a:t>
+            </a:r>
+          </a:p>
+        </p:txBody>
+      </p:sp>
+      <p:sp>
+        <p:nvSpPr>
+          <p:cNvPr id="36" name="TextBox 35"/>
           <p:cNvSpPr txBox="1"/>
           <p:nvPr/>
         </p:nvSpPr>
@@ -53282,7 +53163,7 @@
       </p:sp>
       <p:sp>
         <p:nvSpPr>
-          <p:cNvPr id="35" name="TextBox 34"/>
+          <p:cNvPr id="37" name="TextBox 36"/>
           <p:cNvSpPr txBox="1"/>
           <p:nvPr/>
         </p:nvSpPr>

</xml_diff>